<commit_message>
Atualiza a apresentação do minicurso de TinyML
Substitui aula-tinyml.pptx pela nova versão enviada pelo professor.

Co-Authored-By: Claude Opus 5.5 (1M context) <noreply@anthropic.com>
Claude-Session: https://claude.ai/code/session_01K7x9PhsgBaGsCP2bZqn9yy
</commit_message>
<xml_diff>
--- a/public/arquivos/tinyml/aula-tinyml.pptx
+++ b/public/arquivos/tinyml/aula-tinyml.pptx
@@ -2728,7 +2728,7 @@
           <a:p>
             <a:fld id="{5BCAD085-E8A6-8845-BD4E-CB4CCA059FC4}" type="datetimeFigureOut">
               <a:rPr lang="en-US" smtClean="0"/>
-              <a:t>10/19/2026</a:t>
+              <a:t>10/21/2026</a:t>
             </a:fld>
             <a:endParaRPr lang="en-US"/>
           </a:p>
@@ -2896,7 +2896,7 @@
           <a:p>
             <a:fld id="{5BCAD085-E8A6-8845-BD4E-CB4CCA059FC4}" type="datetimeFigureOut">
               <a:rPr lang="en-US" smtClean="0"/>
-              <a:t>10/19/2026</a:t>
+              <a:t>10/21/2026</a:t>
             </a:fld>
             <a:endParaRPr lang="en-US"/>
           </a:p>
@@ -3074,7 +3074,7 @@
           <a:p>
             <a:fld id="{5BCAD085-E8A6-8845-BD4E-CB4CCA059FC4}" type="datetimeFigureOut">
               <a:rPr lang="en-US" smtClean="0"/>
-              <a:t>10/19/2026</a:t>
+              <a:t>10/21/2026</a:t>
             </a:fld>
             <a:endParaRPr lang="en-US"/>
           </a:p>
@@ -3242,7 +3242,7 @@
           <a:p>
             <a:fld id="{5BCAD085-E8A6-8845-BD4E-CB4CCA059FC4}" type="datetimeFigureOut">
               <a:rPr lang="en-US" smtClean="0"/>
-              <a:t>10/19/2026</a:t>
+              <a:t>10/21/2026</a:t>
             </a:fld>
             <a:endParaRPr lang="en-US"/>
           </a:p>
@@ -3487,7 +3487,7 @@
           <a:p>
             <a:fld id="{5BCAD085-E8A6-8845-BD4E-CB4CCA059FC4}" type="datetimeFigureOut">
               <a:rPr lang="en-US" smtClean="0"/>
-              <a:t>10/19/2026</a:t>
+              <a:t>10/21/2026</a:t>
             </a:fld>
             <a:endParaRPr lang="en-US"/>
           </a:p>
@@ -3772,7 +3772,7 @@
           <a:p>
             <a:fld id="{5BCAD085-E8A6-8845-BD4E-CB4CCA059FC4}" type="datetimeFigureOut">
               <a:rPr lang="en-US" smtClean="0"/>
-              <a:t>10/19/2026</a:t>
+              <a:t>10/21/2026</a:t>
             </a:fld>
             <a:endParaRPr lang="en-US"/>
           </a:p>
@@ -4191,7 +4191,7 @@
           <a:p>
             <a:fld id="{5BCAD085-E8A6-8845-BD4E-CB4CCA059FC4}" type="datetimeFigureOut">
               <a:rPr lang="en-US" smtClean="0"/>
-              <a:t>10/19/2026</a:t>
+              <a:t>10/21/2026</a:t>
             </a:fld>
             <a:endParaRPr lang="en-US"/>
           </a:p>
@@ -4308,7 +4308,7 @@
           <a:p>
             <a:fld id="{5BCAD085-E8A6-8845-BD4E-CB4CCA059FC4}" type="datetimeFigureOut">
               <a:rPr lang="en-US" smtClean="0"/>
-              <a:t>10/19/2026</a:t>
+              <a:t>10/21/2026</a:t>
             </a:fld>
             <a:endParaRPr lang="en-US"/>
           </a:p>
@@ -4403,7 +4403,7 @@
           <a:p>
             <a:fld id="{5BCAD085-E8A6-8845-BD4E-CB4CCA059FC4}" type="datetimeFigureOut">
               <a:rPr lang="en-US" smtClean="0"/>
-              <a:t>10/19/2026</a:t>
+              <a:t>10/21/2026</a:t>
             </a:fld>
             <a:endParaRPr lang="en-US"/>
           </a:p>
@@ -4678,7 +4678,7 @@
           <a:p>
             <a:fld id="{5BCAD085-E8A6-8845-BD4E-CB4CCA059FC4}" type="datetimeFigureOut">
               <a:rPr lang="en-US" smtClean="0"/>
-              <a:t>10/19/2026</a:t>
+              <a:t>10/21/2026</a:t>
             </a:fld>
             <a:endParaRPr lang="en-US"/>
           </a:p>
@@ -4930,7 +4930,7 @@
           <a:p>
             <a:fld id="{5BCAD085-E8A6-8845-BD4E-CB4CCA059FC4}" type="datetimeFigureOut">
               <a:rPr lang="en-US" smtClean="0"/>
-              <a:t>10/19/2026</a:t>
+              <a:t>10/21/2026</a:t>
             </a:fld>
             <a:endParaRPr lang="en-US"/>
           </a:p>
@@ -5141,7 +5141,7 @@
           <a:p>
             <a:fld id="{5BCAD085-E8A6-8845-BD4E-CB4CCA059FC4}" type="datetimeFigureOut">
               <a:rPr lang="en-US" smtClean="0"/>
-              <a:t>10/19/2026</a:t>
+              <a:t>10/21/2026</a:t>
             </a:fld>
             <a:endParaRPr lang="en-US"/>
           </a:p>
@@ -12585,13 +12585,211 @@
           <a:p>
             <a:pPr algn="l"/>
             <a:r>
-              <a:rPr sz="1400" b="0" i="0">
+              <a:rPr sz="1400" b="0" i="0" dirty="0">
                 <a:solidFill>
                   <a:srgbClr val="F4F7FB"/>
                 </a:solidFill>
                 <a:latin typeface="DejaVu Sans"/>
               </a:rPr>
-              <a:t>TensorFlow Lite Micro — hoje parte do Google AI Edge como LiteRT — e seus operadores otimizados executam o modelo dentro do microcontrolador.</a:t>
+              <a:t>TensorFlow Lite Micro — </a:t>
+            </a:r>
+            <a:r>
+              <a:rPr sz="1400" b="0" i="0" dirty="0" err="1">
+                <a:solidFill>
+                  <a:srgbClr val="F4F7FB"/>
+                </a:solidFill>
+                <a:latin typeface="DejaVu Sans"/>
+              </a:rPr>
+              <a:t>hoje</a:t>
+            </a:r>
+            <a:r>
+              <a:rPr sz="1400" b="0" i="0" dirty="0">
+                <a:solidFill>
+                  <a:srgbClr val="F4F7FB"/>
+                </a:solidFill>
+                <a:latin typeface="DejaVu Sans"/>
+              </a:rPr>
+              <a:t> </a:t>
+            </a:r>
+            <a:r>
+              <a:rPr sz="1400" b="0" i="0" dirty="0" err="1">
+                <a:solidFill>
+                  <a:srgbClr val="F4F7FB"/>
+                </a:solidFill>
+                <a:latin typeface="DejaVu Sans"/>
+              </a:rPr>
+              <a:t>parte</a:t>
+            </a:r>
+            <a:r>
+              <a:rPr sz="1400" b="0" i="0" dirty="0">
+                <a:solidFill>
+                  <a:srgbClr val="F4F7FB"/>
+                </a:solidFill>
+                <a:latin typeface="DejaVu Sans"/>
+              </a:rPr>
+              <a:t> do Google AI Edge </a:t>
+            </a:r>
+            <a:r>
+              <a:rPr sz="1400" b="0" i="0" dirty="0" err="1">
+                <a:solidFill>
+                  <a:srgbClr val="F4F7FB"/>
+                </a:solidFill>
+                <a:latin typeface="DejaVu Sans"/>
+              </a:rPr>
+              <a:t>como</a:t>
+            </a:r>
+            <a:r>
+              <a:rPr sz="1400" b="0" i="0" dirty="0">
+                <a:solidFill>
+                  <a:srgbClr val="F4F7FB"/>
+                </a:solidFill>
+                <a:latin typeface="DejaVu Sans"/>
+              </a:rPr>
+              <a:t> </a:t>
+            </a:r>
+            <a:r>
+              <a:rPr sz="1400" b="0" i="0" dirty="0" err="1">
+                <a:solidFill>
+                  <a:srgbClr val="F4F7FB"/>
+                </a:solidFill>
+                <a:latin typeface="DejaVu Sans"/>
+              </a:rPr>
+              <a:t>LiteRT</a:t>
+            </a:r>
+            <a:r>
+              <a:rPr sz="1400" b="0" i="0" dirty="0">
+                <a:solidFill>
+                  <a:srgbClr val="F4F7FB"/>
+                </a:solidFill>
+                <a:latin typeface="DejaVu Sans"/>
+              </a:rPr>
+              <a:t> — e </a:t>
+            </a:r>
+            <a:r>
+              <a:rPr sz="1400" b="0" i="0" dirty="0" err="1">
+                <a:solidFill>
+                  <a:srgbClr val="F4F7FB"/>
+                </a:solidFill>
+                <a:latin typeface="DejaVu Sans"/>
+              </a:rPr>
+              <a:t>seus</a:t>
+            </a:r>
+            <a:r>
+              <a:rPr sz="1400" b="0" i="0" dirty="0">
+                <a:solidFill>
+                  <a:srgbClr val="F4F7FB"/>
+                </a:solidFill>
+                <a:latin typeface="DejaVu Sans"/>
+              </a:rPr>
+              <a:t> </a:t>
+            </a:r>
+            <a:r>
+              <a:rPr sz="1400" b="0" i="0" dirty="0" err="1">
+                <a:solidFill>
+                  <a:srgbClr val="F4F7FB"/>
+                </a:solidFill>
+                <a:latin typeface="DejaVu Sans"/>
+              </a:rPr>
+              <a:t>operadores</a:t>
+            </a:r>
+            <a:r>
+              <a:rPr sz="1400" b="0" i="0" dirty="0">
+                <a:solidFill>
+                  <a:srgbClr val="F4F7FB"/>
+                </a:solidFill>
+                <a:latin typeface="DejaVu Sans"/>
+              </a:rPr>
+              <a:t> </a:t>
+            </a:r>
+            <a:r>
+              <a:rPr sz="1400" b="0" i="0" dirty="0" err="1">
+                <a:solidFill>
+                  <a:srgbClr val="F4F7FB"/>
+                </a:solidFill>
+                <a:latin typeface="DejaVu Sans"/>
+              </a:rPr>
+              <a:t>otimizados</a:t>
+            </a:r>
+            <a:r>
+              <a:rPr sz="1400" b="0" i="0" dirty="0">
+                <a:solidFill>
+                  <a:srgbClr val="F4F7FB"/>
+                </a:solidFill>
+                <a:latin typeface="DejaVu Sans"/>
+              </a:rPr>
+              <a:t> </a:t>
+            </a:r>
+            <a:r>
+              <a:rPr sz="1400" b="0" i="0" dirty="0" err="1">
+                <a:solidFill>
+                  <a:srgbClr val="F4F7FB"/>
+                </a:solidFill>
+                <a:latin typeface="DejaVu Sans"/>
+              </a:rPr>
+              <a:t>executam</a:t>
+            </a:r>
+            <a:r>
+              <a:rPr sz="1400" b="0" i="0" dirty="0">
+                <a:solidFill>
+                  <a:srgbClr val="F4F7FB"/>
+                </a:solidFill>
+                <a:latin typeface="DejaVu Sans"/>
+              </a:rPr>
+              <a:t> o </a:t>
+            </a:r>
+            <a:r>
+              <a:rPr sz="1400" b="0" i="0" dirty="0" err="1">
+                <a:solidFill>
+                  <a:srgbClr val="F4F7FB"/>
+                </a:solidFill>
+                <a:latin typeface="DejaVu Sans"/>
+              </a:rPr>
+              <a:t>modelo</a:t>
+            </a:r>
+            <a:r>
+              <a:rPr sz="1400" b="0" i="0" dirty="0">
+                <a:solidFill>
+                  <a:srgbClr val="F4F7FB"/>
+                </a:solidFill>
+                <a:latin typeface="DejaVu Sans"/>
+              </a:rPr>
+              <a:t> </a:t>
+            </a:r>
+            <a:r>
+              <a:rPr sz="1400" b="0" i="0" dirty="0" err="1">
+                <a:solidFill>
+                  <a:srgbClr val="F4F7FB"/>
+                </a:solidFill>
+                <a:latin typeface="DejaVu Sans"/>
+              </a:rPr>
+              <a:t>dentro</a:t>
+            </a:r>
+            <a:r>
+              <a:rPr sz="1400" b="0" i="0" dirty="0">
+                <a:solidFill>
+                  <a:srgbClr val="F4F7FB"/>
+                </a:solidFill>
+                <a:latin typeface="DejaVu Sans"/>
+              </a:rPr>
+              <a:t> do </a:t>
+            </a:r>
+            <a:r>
+              <a:rPr sz="1400" b="0" i="0" dirty="0" err="1">
+                <a:solidFill>
+                  <a:srgbClr val="F4F7FB"/>
+                </a:solidFill>
+                <a:latin typeface="DejaVu Sans"/>
+              </a:rPr>
+              <a:t>microcontrolador</a:t>
+            </a:r>
+            <a:r>
+              <a:rPr sz="1400" b="0" i="0" dirty="0">
+                <a:solidFill>
+                  <a:srgbClr val="F4F7FB"/>
+                </a:solidFill>
+                <a:latin typeface="DejaVu Sans"/>
+              </a:rPr>
+              <a:t>.</a:t>
             </a:r>
           </a:p>
         </p:txBody>
@@ -14314,7 +14512,7 @@
           <a:p>
             <a:pPr algn="l"/>
             <a:r>
-              <a:rPr sz="1350" b="1" i="0">
+              <a:rPr sz="1350" b="1" i="0" dirty="0">
                 <a:solidFill>
                   <a:srgbClr val="F4F7FB"/>
                 </a:solidFill>
@@ -17781,13 +17979,121 @@
           <a:p>
             <a:pPr algn="l"/>
             <a:r>
-              <a:rPr sz="1400" b="0" i="0">
+              <a:rPr sz="1400" b="0" i="0" dirty="0">
                 <a:solidFill>
                   <a:srgbClr val="F4F7FB"/>
                 </a:solidFill>
                 <a:latin typeface="DejaVu Sans"/>
               </a:rPr>
-              <a:t>“Tocar” na mesa  ·  “Agitar” o dispositivo  ·  Círculo no ar  ·  “Sacudir” para desfazer</a:t>
+              <a:t>“</a:t>
+            </a:r>
+            <a:r>
+              <a:rPr sz="1400" b="0" i="0" dirty="0" err="1">
+                <a:solidFill>
+                  <a:srgbClr val="F4F7FB"/>
+                </a:solidFill>
+                <a:latin typeface="DejaVu Sans"/>
+              </a:rPr>
+              <a:t>Tocar</a:t>
+            </a:r>
+            <a:r>
+              <a:rPr sz="1400" b="0" i="0" dirty="0">
+                <a:solidFill>
+                  <a:srgbClr val="F4F7FB"/>
+                </a:solidFill>
+                <a:latin typeface="DejaVu Sans"/>
+              </a:rPr>
+              <a:t>” </a:t>
+            </a:r>
+            <a:r>
+              <a:rPr sz="1400" b="0" i="0" dirty="0" err="1">
+                <a:solidFill>
+                  <a:srgbClr val="F4F7FB"/>
+                </a:solidFill>
+                <a:latin typeface="DejaVu Sans"/>
+              </a:rPr>
+              <a:t>na</a:t>
+            </a:r>
+            <a:r>
+              <a:rPr sz="1400" b="0" i="0" dirty="0">
+                <a:solidFill>
+                  <a:srgbClr val="F4F7FB"/>
+                </a:solidFill>
+                <a:latin typeface="DejaVu Sans"/>
+              </a:rPr>
+              <a:t> mesa  ·  “</a:t>
+            </a:r>
+            <a:r>
+              <a:rPr sz="1400" b="0" i="0" dirty="0" err="1">
+                <a:solidFill>
+                  <a:srgbClr val="F4F7FB"/>
+                </a:solidFill>
+                <a:latin typeface="DejaVu Sans"/>
+              </a:rPr>
+              <a:t>Agitar</a:t>
+            </a:r>
+            <a:r>
+              <a:rPr sz="1400" b="0" i="0" dirty="0">
+                <a:solidFill>
+                  <a:srgbClr val="F4F7FB"/>
+                </a:solidFill>
+                <a:latin typeface="DejaVu Sans"/>
+              </a:rPr>
+              <a:t>” o </a:t>
+            </a:r>
+            <a:r>
+              <a:rPr sz="1400" b="0" i="0" dirty="0" err="1">
+                <a:solidFill>
+                  <a:srgbClr val="F4F7FB"/>
+                </a:solidFill>
+                <a:latin typeface="DejaVu Sans"/>
+              </a:rPr>
+              <a:t>dispositivo</a:t>
+            </a:r>
+            <a:r>
+              <a:rPr sz="1400" b="0" i="0" dirty="0">
+                <a:solidFill>
+                  <a:srgbClr val="F4F7FB"/>
+                </a:solidFill>
+                <a:latin typeface="DejaVu Sans"/>
+              </a:rPr>
+              <a:t>  ·  </a:t>
+            </a:r>
+            <a:r>
+              <a:rPr sz="1400" b="0" i="0" dirty="0" err="1">
+                <a:solidFill>
+                  <a:srgbClr val="F4F7FB"/>
+                </a:solidFill>
+                <a:latin typeface="DejaVu Sans"/>
+              </a:rPr>
+              <a:t>Círculo</a:t>
+            </a:r>
+            <a:r>
+              <a:rPr sz="1400" b="0" i="0" dirty="0">
+                <a:solidFill>
+                  <a:srgbClr val="F4F7FB"/>
+                </a:solidFill>
+                <a:latin typeface="DejaVu Sans"/>
+              </a:rPr>
+              <a:t> no </a:t>
+            </a:r>
+            <a:r>
+              <a:rPr sz="1400" b="0" i="0" dirty="0" err="1">
+                <a:solidFill>
+                  <a:srgbClr val="F4F7FB"/>
+                </a:solidFill>
+                <a:latin typeface="DejaVu Sans"/>
+              </a:rPr>
+              <a:t>ar</a:t>
+            </a:r>
+            <a:r>
+              <a:rPr sz="1400" b="0" i="0" dirty="0">
+                <a:solidFill>
+                  <a:srgbClr val="F4F7FB"/>
+                </a:solidFill>
+                <a:latin typeface="DejaVu Sans"/>
+              </a:rPr>
+              <a:t>  ·  </a:t>
             </a:r>
           </a:p>
         </p:txBody>
@@ -17816,13 +18122,238 @@
           <a:p>
             <a:pPr algn="l"/>
             <a:r>
-              <a:rPr sz="1400" b="0" i="0">
+              <a:rPr sz="1400" b="0" i="0" dirty="0" err="1">
                 <a:solidFill>
                   <a:srgbClr val="AFC0D3"/>
                 </a:solidFill>
                 <a:latin typeface="DejaVu Sans"/>
               </a:rPr>
-              <a:t>Gestos bem distintos produzem assinaturas bem distintas — a dica para escolher os movimentos da atividade prática.</a:t>
+              <a:t>Gestos</a:t>
+            </a:r>
+            <a:r>
+              <a:rPr sz="1400" b="0" i="0" dirty="0">
+                <a:solidFill>
+                  <a:srgbClr val="AFC0D3"/>
+                </a:solidFill>
+                <a:latin typeface="DejaVu Sans"/>
+              </a:rPr>
+              <a:t> </a:t>
+            </a:r>
+            <a:r>
+              <a:rPr sz="1400" b="0" i="0" dirty="0" err="1">
+                <a:solidFill>
+                  <a:srgbClr val="AFC0D3"/>
+                </a:solidFill>
+                <a:latin typeface="DejaVu Sans"/>
+              </a:rPr>
+              <a:t>bem</a:t>
+            </a:r>
+            <a:r>
+              <a:rPr sz="1400" b="0" i="0" dirty="0">
+                <a:solidFill>
+                  <a:srgbClr val="AFC0D3"/>
+                </a:solidFill>
+                <a:latin typeface="DejaVu Sans"/>
+              </a:rPr>
+              <a:t> </a:t>
+            </a:r>
+            <a:r>
+              <a:rPr sz="1400" b="0" i="0" dirty="0" err="1">
+                <a:solidFill>
+                  <a:srgbClr val="AFC0D3"/>
+                </a:solidFill>
+                <a:latin typeface="DejaVu Sans"/>
+              </a:rPr>
+              <a:t>distintos</a:t>
+            </a:r>
+            <a:r>
+              <a:rPr sz="1400" b="0" i="0" dirty="0">
+                <a:solidFill>
+                  <a:srgbClr val="AFC0D3"/>
+                </a:solidFill>
+                <a:latin typeface="DejaVu Sans"/>
+              </a:rPr>
+              <a:t> </a:t>
+            </a:r>
+            <a:r>
+              <a:rPr sz="1400" b="0" i="0" dirty="0" err="1">
+                <a:solidFill>
+                  <a:srgbClr val="AFC0D3"/>
+                </a:solidFill>
+                <a:latin typeface="DejaVu Sans"/>
+              </a:rPr>
+              <a:t>produzem</a:t>
+            </a:r>
+            <a:r>
+              <a:rPr sz="1400" b="0" i="0" dirty="0">
+                <a:solidFill>
+                  <a:srgbClr val="AFC0D3"/>
+                </a:solidFill>
+                <a:latin typeface="DejaVu Sans"/>
+              </a:rPr>
+              <a:t> </a:t>
+            </a:r>
+            <a:r>
+              <a:rPr sz="1400" b="0" i="0" dirty="0" err="1">
+                <a:solidFill>
+                  <a:srgbClr val="AFC0D3"/>
+                </a:solidFill>
+                <a:latin typeface="DejaVu Sans"/>
+              </a:rPr>
+              <a:t>assinaturas</a:t>
+            </a:r>
+            <a:r>
+              <a:rPr sz="1400" b="0" i="0" dirty="0">
+                <a:solidFill>
+                  <a:srgbClr val="AFC0D3"/>
+                </a:solidFill>
+                <a:latin typeface="DejaVu Sans"/>
+              </a:rPr>
+              <a:t> </a:t>
+            </a:r>
+            <a:r>
+              <a:rPr sz="1400" b="0" i="0" dirty="0" err="1">
+                <a:solidFill>
+                  <a:srgbClr val="AFC0D3"/>
+                </a:solidFill>
+                <a:latin typeface="DejaVu Sans"/>
+              </a:rPr>
+              <a:t>bem</a:t>
+            </a:r>
+            <a:r>
+              <a:rPr sz="1400" b="0" i="0" dirty="0">
+                <a:solidFill>
+                  <a:srgbClr val="AFC0D3"/>
+                </a:solidFill>
+                <a:latin typeface="DejaVu Sans"/>
+              </a:rPr>
+              <a:t> </a:t>
+            </a:r>
+            <a:r>
+              <a:rPr sz="1400" b="0" i="0" dirty="0" err="1">
+                <a:solidFill>
+                  <a:srgbClr val="AFC0D3"/>
+                </a:solidFill>
+                <a:latin typeface="DejaVu Sans"/>
+              </a:rPr>
+              <a:t>distintas</a:t>
+            </a:r>
+            <a:r>
+              <a:rPr sz="1400" b="0" i="0" dirty="0">
+                <a:solidFill>
+                  <a:srgbClr val="AFC0D3"/>
+                </a:solidFill>
+                <a:latin typeface="DejaVu Sans"/>
+              </a:rPr>
+              <a:t> — a </a:t>
+            </a:r>
+            <a:r>
+              <a:rPr sz="1400" b="0" i="0" dirty="0" err="1">
+                <a:solidFill>
+                  <a:srgbClr val="AFC0D3"/>
+                </a:solidFill>
+                <a:latin typeface="DejaVu Sans"/>
+              </a:rPr>
+              <a:t>dica</a:t>
+            </a:r>
+            <a:r>
+              <a:rPr sz="1400" b="0" i="0" dirty="0">
+                <a:solidFill>
+                  <a:srgbClr val="AFC0D3"/>
+                </a:solidFill>
+                <a:latin typeface="DejaVu Sans"/>
+              </a:rPr>
+              <a:t> para </a:t>
+            </a:r>
+            <a:r>
+              <a:rPr sz="1400" b="0" i="0" dirty="0" err="1">
+                <a:solidFill>
+                  <a:srgbClr val="AFC0D3"/>
+                </a:solidFill>
+                <a:latin typeface="DejaVu Sans"/>
+              </a:rPr>
+              <a:t>escolher</a:t>
+            </a:r>
+            <a:r>
+              <a:rPr sz="1400" b="0" i="0" dirty="0">
+                <a:solidFill>
+                  <a:srgbClr val="AFC0D3"/>
+                </a:solidFill>
+                <a:latin typeface="DejaVu Sans"/>
+              </a:rPr>
+              <a:t> </a:t>
+            </a:r>
+            <a:r>
+              <a:rPr sz="1400" b="0" i="0" dirty="0" err="1">
+                <a:solidFill>
+                  <a:srgbClr val="AFC0D3"/>
+                </a:solidFill>
+                <a:latin typeface="DejaVu Sans"/>
+              </a:rPr>
+              <a:t>os</a:t>
+            </a:r>
+            <a:r>
+              <a:rPr sz="1400" b="0" i="0" dirty="0">
+                <a:solidFill>
+                  <a:srgbClr val="AFC0D3"/>
+                </a:solidFill>
+                <a:latin typeface="DejaVu Sans"/>
+              </a:rPr>
+              <a:t> </a:t>
+            </a:r>
+            <a:r>
+              <a:rPr sz="1400" b="0" i="0" dirty="0" err="1">
+                <a:solidFill>
+                  <a:srgbClr val="AFC0D3"/>
+                </a:solidFill>
+                <a:latin typeface="DejaVu Sans"/>
+              </a:rPr>
+              <a:t>movimentos</a:t>
+            </a:r>
+            <a:r>
+              <a:rPr sz="1400" b="0" i="0" dirty="0">
+                <a:solidFill>
+                  <a:srgbClr val="AFC0D3"/>
+                </a:solidFill>
+                <a:latin typeface="DejaVu Sans"/>
+              </a:rPr>
+              <a:t> da </a:t>
+            </a:r>
+            <a:r>
+              <a:rPr sz="1400" b="0" i="0" dirty="0" err="1">
+                <a:solidFill>
+                  <a:srgbClr val="AFC0D3"/>
+                </a:solidFill>
+                <a:latin typeface="DejaVu Sans"/>
+              </a:rPr>
+              <a:t>atividade</a:t>
+            </a:r>
+            <a:r>
+              <a:rPr sz="1400" b="0" i="0" dirty="0">
+                <a:solidFill>
+                  <a:srgbClr val="AFC0D3"/>
+                </a:solidFill>
+                <a:latin typeface="DejaVu Sans"/>
+              </a:rPr>
+              <a:t> </a:t>
+            </a:r>
+            <a:r>
+              <a:rPr sz="1400" b="0" i="0" dirty="0" err="1">
+                <a:solidFill>
+                  <a:srgbClr val="AFC0D3"/>
+                </a:solidFill>
+                <a:latin typeface="DejaVu Sans"/>
+              </a:rPr>
+              <a:t>prática</a:t>
+            </a:r>
+            <a:r>
+              <a:rPr sz="1400" b="0" i="0" dirty="0">
+                <a:solidFill>
+                  <a:srgbClr val="AFC0D3"/>
+                </a:solidFill>
+                <a:latin typeface="DejaVu Sans"/>
+              </a:rPr>
+              <a:t>.</a:t>
             </a:r>
           </a:p>
         </p:txBody>
@@ -19081,108 +19612,13 @@
           <a:lstStyle/>
           <a:p>
             <a:pPr algn="l"/>
-            <a:r>
-              <a:rPr sz="1600" b="1" i="0" dirty="0" err="1">
-                <a:solidFill>
-                  <a:srgbClr val="F4F7FB"/>
-                </a:solidFill>
-                <a:latin typeface="DejaVu Sans"/>
-              </a:rPr>
-              <a:t>Vídeo</a:t>
-            </a:r>
-            <a:r>
-              <a:rPr sz="1600" b="1" i="0" dirty="0">
-                <a:solidFill>
-                  <a:srgbClr val="F4F7FB"/>
-                </a:solidFill>
-                <a:latin typeface="DejaVu Sans"/>
-              </a:rPr>
-              <a:t>: O </a:t>
-            </a:r>
-            <a:r>
-              <a:rPr sz="1600" b="1" i="0" dirty="0" err="1">
-                <a:solidFill>
-                  <a:srgbClr val="F4F7FB"/>
-                </a:solidFill>
-                <a:latin typeface="DejaVu Sans"/>
-              </a:rPr>
-              <a:t>que</a:t>
-            </a:r>
-            <a:r>
-              <a:rPr sz="1600" b="1" i="0" dirty="0">
-                <a:solidFill>
-                  <a:srgbClr val="F4F7FB"/>
-                </a:solidFill>
-                <a:latin typeface="DejaVu Sans"/>
-              </a:rPr>
-              <a:t> é </a:t>
-            </a:r>
-            <a:r>
-              <a:rPr sz="1600" b="1" i="0" dirty="0" err="1">
-                <a:solidFill>
-                  <a:srgbClr val="F4F7FB"/>
-                </a:solidFill>
-                <a:latin typeface="DejaVu Sans"/>
-              </a:rPr>
-              <a:t>TinyML</a:t>
-            </a:r>
-            <a:r>
-              <a:rPr sz="1600" b="1" i="0" dirty="0">
-                <a:solidFill>
-                  <a:srgbClr val="F4F7FB"/>
-                </a:solidFill>
-                <a:latin typeface="DejaVu Sans"/>
-              </a:rPr>
-              <a:t>? (alternativo) — UNIFEI - </a:t>
-            </a:r>
-            <a:r>
-              <a:rPr sz="1600" b="1" i="0" dirty="0" err="1">
-                <a:solidFill>
-                  <a:srgbClr val="F4F7FB"/>
-                </a:solidFill>
-                <a:latin typeface="DejaVu Sans"/>
-              </a:rPr>
-              <a:t>TinyML</a:t>
-            </a:r>
-            <a:r>
-              <a:rPr sz="1600" b="1" i="0" dirty="0">
-                <a:solidFill>
-                  <a:srgbClr val="F4F7FB"/>
-                </a:solidFill>
-                <a:latin typeface="DejaVu Sans"/>
-              </a:rPr>
-              <a:t> - IESTI01 2022.1 - Class 02 - Introduction to </a:t>
-            </a:r>
-            <a:r>
-              <a:rPr sz="1600" b="1" i="0" dirty="0" err="1">
-                <a:solidFill>
-                  <a:srgbClr val="F4F7FB"/>
-                </a:solidFill>
-                <a:latin typeface="DejaVu Sans"/>
-              </a:rPr>
-              <a:t>TinyML</a:t>
-            </a:r>
-            <a:r>
-              <a:rPr sz="1600" b="1" i="0" dirty="0">
-                <a:solidFill>
-                  <a:srgbClr val="F4F7FB"/>
-                </a:solidFill>
-                <a:latin typeface="DejaVu Sans"/>
-              </a:rPr>
-              <a:t> (Marcelo Rovai)</a:t>
-            </a:r>
-          </a:p>
-          <a:p>
-            <a:r>
-              <a:rPr sz="1600" b="0" i="0" dirty="0">
-                <a:solidFill>
-                  <a:srgbClr val="36D1DC"/>
-                </a:solidFill>
-                <a:latin typeface="DejaVu Sans"/>
-                <a:hlinkClick r:id="rId4"/>
-              </a:rPr>
-              <a:t>https://www.youtube.com/watch?v=7qeoZdYNGJA</a:t>
-            </a:r>
+            <a:endParaRPr sz="1600" b="0" i="0" dirty="0">
+              <a:solidFill>
+                <a:srgbClr val="36D1DC"/>
+              </a:solidFill>
+              <a:latin typeface="DejaVu Sans"/>
+              <a:hlinkClick r:id="rId4"/>
+            </a:endParaRPr>
           </a:p>
         </p:txBody>
       </p:sp>
@@ -19416,16 +19852,111 @@
           </a:bodyPr>
           <a:lstStyle/>
           <a:p>
-            <a:pPr algn="l"/>
-            <a:r>
-              <a:rPr sz="1400" b="0" i="0">
+            <a:r>
+              <a:rPr sz="1400" b="0" i="0" dirty="0">
                 <a:solidFill>
                   <a:srgbClr val="AFC0D3"/>
                 </a:solidFill>
                 <a:latin typeface="DejaVu Sans"/>
               </a:rPr>
-              <a:t>A plataforma end-to-end que usaremos na prática</a:t>
-            </a:r>
+              <a:t>A </a:t>
+            </a:r>
+            <a:r>
+              <a:rPr sz="1400" b="0" i="0" dirty="0" err="1">
+                <a:solidFill>
+                  <a:srgbClr val="AFC0D3"/>
+                </a:solidFill>
+                <a:latin typeface="DejaVu Sans"/>
+              </a:rPr>
+              <a:t>plataforma</a:t>
+            </a:r>
+            <a:r>
+              <a:rPr sz="1400" b="0" i="0" dirty="0">
+                <a:solidFill>
+                  <a:srgbClr val="AFC0D3"/>
+                </a:solidFill>
+                <a:latin typeface="DejaVu Sans"/>
+              </a:rPr>
+              <a:t> end-to-end </a:t>
+            </a:r>
+            <a:r>
+              <a:rPr sz="1400" b="0" i="0" dirty="0" err="1">
+                <a:solidFill>
+                  <a:srgbClr val="AFC0D3"/>
+                </a:solidFill>
+                <a:latin typeface="DejaVu Sans"/>
+              </a:rPr>
+              <a:t>que</a:t>
+            </a:r>
+            <a:r>
+              <a:rPr sz="1400" b="0" i="0" dirty="0">
+                <a:solidFill>
+                  <a:srgbClr val="AFC0D3"/>
+                </a:solidFill>
+                <a:latin typeface="DejaVu Sans"/>
+              </a:rPr>
+              <a:t> </a:t>
+            </a:r>
+            <a:r>
+              <a:rPr sz="1400" b="0" i="0" dirty="0" err="1">
+                <a:solidFill>
+                  <a:srgbClr val="AFC0D3"/>
+                </a:solidFill>
+                <a:latin typeface="DejaVu Sans"/>
+              </a:rPr>
+              <a:t>usaremos</a:t>
+            </a:r>
+            <a:r>
+              <a:rPr sz="1400" b="0" i="0" dirty="0">
+                <a:solidFill>
+                  <a:srgbClr val="AFC0D3"/>
+                </a:solidFill>
+                <a:latin typeface="DejaVu Sans"/>
+              </a:rPr>
+              <a:t> </a:t>
+            </a:r>
+            <a:r>
+              <a:rPr sz="1400" b="0" i="0" dirty="0" err="1">
+                <a:solidFill>
+                  <a:srgbClr val="AFC0D3"/>
+                </a:solidFill>
+                <a:latin typeface="DejaVu Sans"/>
+              </a:rPr>
+              <a:t>na</a:t>
+            </a:r>
+            <a:r>
+              <a:rPr sz="1400" b="0" i="0" dirty="0">
+                <a:solidFill>
+                  <a:srgbClr val="AFC0D3"/>
+                </a:solidFill>
+                <a:latin typeface="DejaVu Sans"/>
+              </a:rPr>
+              <a:t> </a:t>
+            </a:r>
+            <a:r>
+              <a:rPr sz="1400" b="0" i="0" dirty="0" err="1">
+                <a:solidFill>
+                  <a:srgbClr val="AFC0D3"/>
+                </a:solidFill>
+                <a:latin typeface="DejaVu Sans"/>
+              </a:rPr>
+              <a:t>prática</a:t>
+            </a:r>
+            <a:r>
+              <a:rPr lang="pt-BR" sz="1400" dirty="0">
+                <a:solidFill>
+                  <a:srgbClr val="AFC0D3"/>
+                </a:solidFill>
+                <a:latin typeface="DejaVu Sans"/>
+              </a:rPr>
+              <a:t>: https://www.edgeimpulse.com/</a:t>
+            </a:r>
+            <a:endParaRPr sz="1400" b="0" i="0" dirty="0">
+              <a:solidFill>
+                <a:srgbClr val="AFC0D3"/>
+              </a:solidFill>
+              <a:latin typeface="DejaVu Sans"/>
+            </a:endParaRPr>
           </a:p>
         </p:txBody>
       </p:sp>
@@ -34061,7 +34592,7 @@
           <a:p>
             <a:pPr algn="l"/>
             <a:r>
-              <a:rPr sz="1700" b="1" i="0">
+              <a:rPr sz="1700" b="1" i="0" dirty="0">
                 <a:solidFill>
                   <a:srgbClr val="F4F7FB"/>
                 </a:solidFill>
@@ -34096,14 +34627,20 @@
           <a:p>
             <a:pPr algn="l"/>
             <a:r>
-              <a:rPr sz="1300" b="0" i="0">
+              <a:rPr lang="pt-BR" sz="1300" b="0" i="0">
                 <a:solidFill>
                   <a:srgbClr val="AFC0D3"/>
                 </a:solidFill>
                 <a:latin typeface="DejaVu Sans"/>
               </a:rPr>
-              <a:t>Exemplos coletados e rotulados</a:t>
-            </a:r>
+              <a:t>Dados e experiências — Exemplos, observações ou interações</a:t>
+            </a:r>
+            <a:endParaRPr sz="1300" b="0" i="0" dirty="0">
+              <a:solidFill>
+                <a:srgbClr val="AFC0D3"/>
+              </a:solidFill>
+              <a:latin typeface="DejaVu Sans"/>
+            </a:endParaRPr>
           </a:p>
         </p:txBody>
       </p:sp>
@@ -34798,14 +35335,20 @@
           <a:p>
             <a:pPr algn="l"/>
             <a:r>
-              <a:rPr sz="1300" b="0" i="0">
+              <a:rPr lang="pt-BR" sz="1300" b="0" i="0">
                 <a:solidFill>
                   <a:srgbClr val="AFC0D3"/>
                 </a:solidFill>
                 <a:latin typeface="DejaVu Sans"/>
               </a:rPr>
-              <a:t>Predição com dados novos</a:t>
-            </a:r>
+              <a:t>Uso do modelo — Previsões, padrões ou decisões</a:t>
+            </a:r>
+            <a:endParaRPr sz="1300" b="0" i="0" dirty="0">
+              <a:solidFill>
+                <a:srgbClr val="AFC0D3"/>
+              </a:solidFill>
+              <a:latin typeface="DejaVu Sans"/>
+            </a:endParaRPr>
           </a:p>
         </p:txBody>
       </p:sp>

</xml_diff>